<commit_message>
Improved UI, added About page
</commit_message>
<xml_diff>
--- a/docs/presentation.pptx
+++ b/docs/presentation.pptx
@@ -5385,33 +5385,9 @@
           </a:p>
         </p:txBody>
       </p:sp>
-      <p:pic>
-        <p:nvPicPr>
-          <p:cNvPr id="7" name="Picture 6" descr="overview_A.png"/>
-          <p:cNvPicPr>
-            <a:picLocks noChangeAspect="1"/>
-          </p:cNvPicPr>
-          <p:nvPr/>
-        </p:nvPicPr>
-        <p:blipFill>
-          <a:blip r:embed="rId3"/>
-          <a:stretch>
-            <a:fillRect/>
-          </a:stretch>
-        </p:blipFill>
-        <p:spPr>
-          <a:xfrm>
-            <a:off x="658368" y="1252728"/>
-            <a:ext cx="5212080" cy="3619500"/>
-          </a:xfrm>
-          <a:prstGeom prst="rect">
-            <a:avLst/>
-          </a:prstGeom>
-        </p:spPr>
-      </p:pic>
-      <p:sp>
-        <p:nvSpPr>
-          <p:cNvPr id="8" name="TextBox 7"/>
+      <p:sp>
+        <p:nvSpPr>
+          <p:cNvPr id="7" name="TextBox 6"/>
           <p:cNvSpPr txBox="1"/>
           <p:nvPr/>
         </p:nvSpPr>
@@ -5446,7 +5422,7 @@
       </p:sp>
       <p:sp>
         <p:nvSpPr>
-          <p:cNvPr id="9" name="Rounded Rectangle 8"/>
+          <p:cNvPr id="8" name="Rounded Rectangle 7"/>
           <p:cNvSpPr/>
           <p:nvPr/>
         </p:nvSpPr>
@@ -5488,33 +5464,9 @@
           </a:p>
         </p:txBody>
       </p:sp>
-      <p:pic>
-        <p:nvPicPr>
-          <p:cNvPr id="10" name="Picture 9" descr="whatif_A.png"/>
-          <p:cNvPicPr>
-            <a:picLocks noChangeAspect="1"/>
-          </p:cNvPicPr>
-          <p:nvPr/>
-        </p:nvPicPr>
-        <p:blipFill>
-          <a:blip r:embed="rId4"/>
-          <a:stretch>
-            <a:fillRect/>
-          </a:stretch>
-        </p:blipFill>
-        <p:spPr>
-          <a:xfrm>
-            <a:off x="6281928" y="1252728"/>
-            <a:ext cx="5212080" cy="3619500"/>
-          </a:xfrm>
-          <a:prstGeom prst="rect">
-            <a:avLst/>
-          </a:prstGeom>
-        </p:spPr>
-      </p:pic>
-      <p:sp>
-        <p:nvSpPr>
-          <p:cNvPr id="11" name="TextBox 10"/>
+      <p:sp>
+        <p:nvSpPr>
+          <p:cNvPr id="9" name="TextBox 8"/>
           <p:cNvSpPr txBox="1"/>
           <p:nvPr/>
         </p:nvSpPr>

</xml_diff>